<commit_message>
docs: actualizar README de App y Web y alinear documentacion comercial y tecnica
- Web/README.md: documenta rutas v7 (/devices, /admin, /admin/devices/:id), panel de soporte, busqueda multicriterio, factory reset, modo claro/oscuro y estado en produccion en Vercel.
- App/README.md: documenta perimetro de predios por GPS, UX offline-first (Zustand + AsyncStorage), protocolo BLE 16B GATT notify, regla de veto por salinidad y suite de 18 pruebas unitarias.
- Alinear README principal, Comercializacion de Tecnologias (README + PPTX anexo) y docs/ con el modelo financiero oficial (.990 CLP, BOM .656 CLP y financiamiento FOGAPE).
</commit_message>
<xml_diff>
--- a/Comercializacion de Tecnologias/TerraSense - Comercializacion de Tecnologias.pptx
+++ b/Comercializacion de Tecnologias/TerraSense - Comercializacion de Tecnologias.pptx
@@ -23,6 +23,7 @@
     <p:sldId id="271" r:id="rId17"/>
     <p:sldId id="272" r:id="rId18"/>
     <p:sldId id="273" r:id="rId19"/>
+    <p:sldId id="274" r:id="rId25"/>
   </p:sldIdLst>
   <p:notesMasterIdLst>
     <p:notesMasterId r:id="rId20"/>
@@ -788,13 +789,38 @@
           <a:lstStyle/>
           <a:p>
             <a:r>
-              <a:rPr lang="en-US" dirty="0"/>
-              <a:t>Explicar VAN y TIR en una frase cada uno: VAN = valor que crea el proyecto hoy descontando el riesgo; TIR = rentabilidad propia del proyecto.
-VAN positivo de $2.588.182 al 20 % y TIR de 22,7 %: supera la exigencia por 2,7 puntos. Payback 3,71 años, dentro del horizonte de 5.
-INTERPRETAR (es lo que pide el criterio): la holgura es moderada. No decir "es muy rentable"; decir "es viable y sensible al volumen".
-Cada salto de ventas tiene una causa financiada en el flujo, no es extrapolación matemática.</a:t>
-            </a:r>
-            <a:endParaRPr lang="en-US" dirty="0"/>
+              <a:t>Explicar VAN y TIR en una frase cada uno: VAN = valor que crea el proyecto hoy descontando el riesgo; TIR = rentabilidad propia del proyecto.</a:t>
+            </a:r>
+          </a:p>
+          <a:p>
+            <a:r>
+              <a:t>VAN positivo de $2.588.182 al 20 % y TIR de 22,7 %: supera la exigencia por 2,7 puntos. Payback 3,71 años, dentro del horizonte de 5.</a:t>
+            </a:r>
+          </a:p>
+          <a:p>
+            <a:r>
+              <a:t>Inversión inicial: $26.548.500 (Activo nominal $4,4M, Capital de trabajo $14,8M, Contingencia $2,4M, Activo fijo $4,9M).</a:t>
+            </a:r>
+          </a:p>
+          <a:p>
+            <a:r>
+              <a:t>Financiamiento: 33,5 % aporte propio de los 2 socios ($8,9M) y 66,5 % bancario con garantía FOGAPE ($12,65M LP a 5 años al 10 % y $5M línea corta al 15 %). 0 % subsidio estatal.</a:t>
+            </a:r>
+          </a:p>
+          <a:p>
+            <a:r>
+              <a:t>Flujo de caja: Año 1 es el único negativo (-$3,28M) por extinción de la línea corta ($5M) y amortización LP ($2,07M), totalizando $7,07M de capital devuelto a banco, absorbido por diseño por el capital de trabajo. Desde Año 2 el flujo es fuertemente positivo (+8,27M a +30,49M), acumulando $36,17M al Año 5.</a:t>
+            </a:r>
+          </a:p>
+          <a:p>
+            <a:r>
+              <a:t>INTERPRETAR (es lo que pide el criterio): la holgura es moderada. No decir 'es muy rentable'; decir 'es viable y sensible al volumen'.</a:t>
+            </a:r>
+          </a:p>
+          <a:p>
+            <a:r>
+              <a:t>Cada salto de ventas tiene una causa financiada en el flujo, no es extrapolación matemática.</a:t>
+            </a:r>
           </a:p>
         </p:txBody>
       </p:sp>
@@ -1366,6 +1392,91 @@
         <p14:creationId xmlns:p14="http://schemas.microsoft.com/office/powerpoint/2010/main" val="1024086991"/>
       </p:ext>
     </p:extLst>
+  </p:cSld>
+  <p:clrMapOvr>
+    <a:masterClrMapping/>
+  </p:clrMapOvr>
+</p:notes>
+</file>
+
+<file path=ppt/notesSlides/notesSlide19.xml><?xml version="1.0" encoding="utf-8"?>
+<p:notes xmlns:a="http://schemas.openxmlformats.org/drawingml/2006/main" xmlns:p="http://schemas.openxmlformats.org/presentationml/2006/main" xmlns:r="http://schemas.openxmlformats.org/officeDocument/2006/relationships">
+  <p:cSld>
+    <p:spTree>
+      <p:nvGrpSpPr>
+        <p:cNvPr id="1" name=""/>
+        <p:cNvGrpSpPr/>
+        <p:nvPr/>
+      </p:nvGrpSpPr>
+      <p:grpSpPr>
+        <a:xfrm>
+          <a:off x="0" y="0"/>
+          <a:ext cx="0" cy="0"/>
+          <a:chOff x="0" y="0"/>
+          <a:chExt cx="0" cy="0"/>
+        </a:xfrm>
+      </p:grpSpPr>
+      <p:sp>
+        <p:nvSpPr>
+          <p:cNvPr id="2" name="Slide Image Placeholder 1"/>
+          <p:cNvSpPr>
+            <a:spLocks noGrp="1"/>
+          </p:cNvSpPr>
+          <p:nvPr>
+            <p:ph type="sldImg" idx="2"/>
+          </p:nvPr>
+        </p:nvSpPr>
+        <p:spPr/>
+      </p:sp>
+      <p:sp>
+        <p:nvSpPr>
+          <p:cNvPr id="3" name="Notes Placeholder 2"/>
+          <p:cNvSpPr>
+            <a:spLocks noGrp="1"/>
+          </p:cNvSpPr>
+          <p:nvPr>
+            <p:ph type="body" idx="3" sz="quarter"/>
+          </p:nvPr>
+        </p:nvSpPr>
+        <p:spPr/>
+        <p:txBody>
+          <a:bodyPr/>
+          <a:lstStyle/>
+          <a:p>
+            <a:r>
+              <a:t>Diapositiva de respaldo para responder preguntas de la comisión sobre finanzas, financiamiento y liquidez.</a:t>
+            </a:r>
+          </a:p>
+          <a:p>
+            <a:r>
+              <a:t>Dominar la diferencia clave: utilidad neta (contable) vs flujo de caja (salidas reales de dinero).</a:t>
+            </a:r>
+          </a:p>
+          <a:p>
+            <a:r>
+              <a:t>Enfatizar el rol de FOGAPE y del aporte de los socios para hacer aprobable el crédito bancario.</a:t>
+            </a:r>
+          </a:p>
+          <a:p>
+            <a:r>
+              <a:t>Explicar que el capital de trabajo absorbe el pago de la línea corta del primer año.</a:t>
+            </a:r>
+          </a:p>
+        </p:txBody>
+      </p:sp>
+      <p:sp>
+        <p:nvSpPr>
+          <p:cNvPr id="4" name="Slide Number Placeholder 3"/>
+          <p:cNvSpPr>
+            <a:spLocks noGrp="1"/>
+          </p:cNvSpPr>
+          <p:nvPr>
+            <p:ph type="sldNum" idx="5" sz="quarter"/>
+          </p:nvPr>
+        </p:nvSpPr>
+        <p:spPr/>
+      </p:sp>
+    </p:spTree>
   </p:cSld>
   <p:clrMapOvr>
     <a:masterClrMapping/>
@@ -15071,6 +15182,820 @@
 </p:sld>
 </file>
 
+<file path=ppt/slides/slide19.xml><?xml version="1.0" encoding="utf-8"?>
+<p:sld xmlns:a="http://schemas.openxmlformats.org/drawingml/2006/main" xmlns:p="http://schemas.openxmlformats.org/presentationml/2006/main" xmlns:r="http://schemas.openxmlformats.org/officeDocument/2006/relationships">
+  <p:cSld>
+    <p:spTree>
+      <p:nvGrpSpPr>
+        <p:cNvPr id="1" name=""/>
+        <p:cNvGrpSpPr/>
+        <p:nvPr/>
+      </p:nvGrpSpPr>
+      <p:grpSpPr/>
+      <p:sp>
+        <p:nvSpPr>
+          <p:cNvPr id="2" name="Text 0"/>
+          <p:cNvSpPr/>
+          <p:nvPr/>
+        </p:nvSpPr>
+        <p:spPr>
+          <a:xfrm>
+            <a:off x="530352" y="274320"/>
+            <a:ext cx="914400" cy="228600"/>
+          </a:xfrm>
+          <a:prstGeom prst="rect">
+            <a:avLst/>
+          </a:prstGeom>
+          <a:noFill/>
+          <a:ln/>
+        </p:spPr>
+        <p:txBody>
+          <a:bodyPr wrap="square" rtlCol="0" anchor="ctr"/>
+          <a:lstStyle/>
+          <a:p>
+            <a:r>
+              <a:t>18</a:t>
+            </a:r>
+          </a:p>
+        </p:txBody>
+      </p:sp>
+      <p:sp>
+        <p:nvSpPr>
+          <p:cNvPr id="3" name="Text 1"/>
+          <p:cNvSpPr/>
+          <p:nvPr/>
+        </p:nvSpPr>
+        <p:spPr>
+          <a:xfrm>
+            <a:off x="8001000" y="274320"/>
+            <a:ext cx="3657600" cy="228600"/>
+          </a:xfrm>
+          <a:prstGeom prst="rect">
+            <a:avLst/>
+          </a:prstGeom>
+          <a:noFill/>
+          <a:ln/>
+        </p:spPr>
+        <p:txBody>
+          <a:bodyPr wrap="square" rtlCol="0" anchor="ctr"/>
+          <a:lstStyle/>
+          <a:p>
+            <a:r>
+              <a:t>ANEXO DE RESPALDO</a:t>
+            </a:r>
+          </a:p>
+        </p:txBody>
+      </p:sp>
+      <p:sp>
+        <p:nvSpPr>
+          <p:cNvPr id="4" name="Text 2"/>
+          <p:cNvSpPr/>
+          <p:nvPr/>
+        </p:nvSpPr>
+        <p:spPr>
+          <a:xfrm>
+            <a:off x="530352" y="502920"/>
+            <a:ext cx="11128248" cy="566928"/>
+          </a:xfrm>
+          <a:prstGeom prst="rect">
+            <a:avLst/>
+          </a:prstGeom>
+          <a:noFill/>
+          <a:ln/>
+        </p:spPr>
+        <p:txBody>
+          <a:bodyPr wrap="square" rtlCol="0" anchor="ctr"/>
+          <a:lstStyle/>
+          <a:p>
+            <a:r>
+              <a:t>Financiamiento, flujo de caja y capital de trabajo</a:t>
+            </a:r>
+          </a:p>
+        </p:txBody>
+      </p:sp>
+      <p:sp>
+        <p:nvSpPr>
+          <p:cNvPr id="5" name="Shape 3"/>
+          <p:cNvSpPr/>
+          <p:nvPr/>
+        </p:nvSpPr>
+        <p:spPr>
+          <a:xfrm>
+            <a:off x="530352" y="1170432"/>
+            <a:ext cx="11128248" cy="32004"/>
+          </a:xfrm>
+          <a:prstGeom prst="rect">
+            <a:avLst/>
+          </a:prstGeom>
+          <a:solidFill>
+            <a:srgbClr val="B02A26"/>
+          </a:solidFill>
+          <a:ln w="12700">
+            <a:solidFill>
+              <a:srgbClr val="B02A26"/>
+            </a:solidFill>
+            <a:prstDash val="solid"/>
+          </a:ln>
+        </p:spPr>
+      </p:sp>
+      <p:sp>
+        <p:nvSpPr>
+          <p:cNvPr id="6" name="Text 4"/>
+          <p:cNvSpPr/>
+          <p:nvPr/>
+        </p:nvSpPr>
+        <p:spPr>
+          <a:xfrm>
+            <a:off x="530352" y="6382512"/>
+            <a:ext cx="10579608" cy="228600"/>
+          </a:xfrm>
+          <a:prstGeom prst="rect">
+            <a:avLst/>
+          </a:prstGeom>
+          <a:noFill/>
+          <a:ln/>
+        </p:spPr>
+        <p:txBody>
+          <a:bodyPr wrap="square" rtlCol="0" anchor="ctr"/>
+          <a:lstStyle/>
+          <a:p>
+            <a:r>
+              <a:t>Diapositiva de respaldo: no se expone, se usa sólo si la comisión profundiza en finanzas.</a:t>
+            </a:r>
+          </a:p>
+        </p:txBody>
+      </p:sp>
+      <p:sp>
+        <p:nvSpPr>
+          <p:cNvPr id="7" name="Text 5"/>
+          <p:cNvSpPr/>
+          <p:nvPr/>
+        </p:nvSpPr>
+        <p:spPr>
+          <a:xfrm>
+            <a:off x="11475720" y="6382512"/>
+            <a:ext cx="457200" cy="228600"/>
+          </a:xfrm>
+          <a:prstGeom prst="rect">
+            <a:avLst/>
+          </a:prstGeom>
+          <a:noFill/>
+          <a:ln/>
+        </p:spPr>
+        <p:txBody>
+          <a:bodyPr wrap="square" rtlCol="0" anchor="ctr"/>
+          <a:lstStyle/>
+          <a:p>
+            <a:r>
+              <a:t>18</a:t>
+            </a:r>
+          </a:p>
+        </p:txBody>
+      </p:sp>
+      <p:sp>
+        <p:nvSpPr>
+          <p:cNvPr id="8" name="Shape 6"/>
+          <p:cNvSpPr/>
+          <p:nvPr/>
+        </p:nvSpPr>
+        <p:spPr>
+          <a:xfrm>
+            <a:off x="530352" y="1426464"/>
+            <a:ext cx="5440680" cy="1444752"/>
+          </a:xfrm>
+          <a:prstGeom prst="roundRect">
+            <a:avLst>
+              <a:gd name="adj" fmla="val 3165"/>
+            </a:avLst>
+          </a:prstGeom>
+          <a:solidFill>
+            <a:srgbClr val="FFFFFF"/>
+          </a:solidFill>
+          <a:ln w="12700">
+            <a:solidFill>
+              <a:srgbClr val="E8EAED"/>
+            </a:solidFill>
+            <a:prstDash val="solid"/>
+          </a:ln>
+        </p:spPr>
+      </p:sp>
+      <p:sp>
+        <p:nvSpPr>
+          <p:cNvPr id="9" name="Shape 7"/>
+          <p:cNvSpPr/>
+          <p:nvPr/>
+        </p:nvSpPr>
+        <p:spPr>
+          <a:xfrm>
+            <a:off x="530352" y="1426464"/>
+            <a:ext cx="45720" cy="1444752"/>
+          </a:xfrm>
+          <a:prstGeom prst="rect">
+            <a:avLst/>
+          </a:prstGeom>
+          <a:solidFill>
+            <a:srgbClr val="B02A26"/>
+          </a:solidFill>
+          <a:ln w="12700">
+            <a:solidFill>
+              <a:srgbClr val="B02A26"/>
+            </a:solidFill>
+            <a:prstDash val="solid"/>
+          </a:ln>
+        </p:spPr>
+      </p:sp>
+      <p:sp>
+        <p:nvSpPr>
+          <p:cNvPr id="10" name="Text 8"/>
+          <p:cNvSpPr/>
+          <p:nvPr/>
+        </p:nvSpPr>
+        <p:spPr>
+          <a:xfrm>
+            <a:off x="749808" y="1554480"/>
+            <a:ext cx="5029200" cy="292608"/>
+          </a:xfrm>
+          <a:prstGeom prst="rect">
+            <a:avLst/>
+          </a:prstGeom>
+          <a:noFill/>
+          <a:ln/>
+        </p:spPr>
+        <p:txBody>
+          <a:bodyPr wrap="square" rtlCol="0" anchor="ctr"/>
+          <a:lstStyle/>
+          <a:p>
+            <a:r>
+              <a:t>¿Cómo se financian los $26,5 M de inversión inicial?</a:t>
+            </a:r>
+          </a:p>
+        </p:txBody>
+      </p:sp>
+      <p:sp>
+        <p:nvSpPr>
+          <p:cNvPr id="11" name="Text 9"/>
+          <p:cNvSpPr/>
+          <p:nvPr/>
+        </p:nvSpPr>
+        <p:spPr>
+          <a:xfrm>
+            <a:off x="749808" y="1883664"/>
+            <a:ext cx="5029200" cy="868680"/>
+          </a:xfrm>
+          <a:prstGeom prst="rect">
+            <a:avLst/>
+          </a:prstGeom>
+          <a:noFill/>
+          <a:ln/>
+        </p:spPr>
+        <p:txBody>
+          <a:bodyPr wrap="square" rtlCol="0" anchor="ctr"/>
+          <a:lstStyle/>
+          <a:p>
+            <a:r>
+              <a:t>33,5 % capital propio de los 2 socios ($8.900.000) y 66,5 % bancario con garantía estatal FOGAPE ($12.648.500 a 5 años al 10 % y $5.000.000 línea corta al 15 %). 0 % subsidio estatal.</a:t>
+            </a:r>
+          </a:p>
+        </p:txBody>
+      </p:sp>
+      <p:sp>
+        <p:nvSpPr>
+          <p:cNvPr id="12" name="Shape 10"/>
+          <p:cNvSpPr/>
+          <p:nvPr/>
+        </p:nvSpPr>
+        <p:spPr>
+          <a:xfrm>
+            <a:off x="530352" y="3026664"/>
+            <a:ext cx="5440680" cy="1444752"/>
+          </a:xfrm>
+          <a:prstGeom prst="roundRect">
+            <a:avLst>
+              <a:gd name="adj" fmla="val 3165"/>
+            </a:avLst>
+          </a:prstGeom>
+          <a:solidFill>
+            <a:srgbClr val="FFFFFF"/>
+          </a:solidFill>
+          <a:ln w="12700">
+            <a:solidFill>
+              <a:srgbClr val="E8EAED"/>
+            </a:solidFill>
+            <a:prstDash val="solid"/>
+          </a:ln>
+        </p:spPr>
+      </p:sp>
+      <p:sp>
+        <p:nvSpPr>
+          <p:cNvPr id="13" name="Shape 11"/>
+          <p:cNvSpPr/>
+          <p:nvPr/>
+        </p:nvSpPr>
+        <p:spPr>
+          <a:xfrm>
+            <a:off x="530352" y="3026664"/>
+            <a:ext cx="45720" cy="1444752"/>
+          </a:xfrm>
+          <a:prstGeom prst="rect">
+            <a:avLst/>
+          </a:prstGeom>
+          <a:solidFill>
+            <a:srgbClr val="B02A26"/>
+          </a:solidFill>
+          <a:ln w="12700">
+            <a:solidFill>
+              <a:srgbClr val="B02A26"/>
+            </a:solidFill>
+            <a:prstDash val="solid"/>
+          </a:ln>
+        </p:spPr>
+      </p:sp>
+      <p:sp>
+        <p:nvSpPr>
+          <p:cNvPr id="14" name="Text 12"/>
+          <p:cNvSpPr/>
+          <p:nvPr/>
+        </p:nvSpPr>
+        <p:spPr>
+          <a:xfrm>
+            <a:off x="749808" y="3154680"/>
+            <a:ext cx="5029200" cy="292608"/>
+          </a:xfrm>
+          <a:prstGeom prst="rect">
+            <a:avLst/>
+          </a:prstGeom>
+          <a:noFill/>
+          <a:ln/>
+        </p:spPr>
+        <p:txBody>
+          <a:bodyPr wrap="square" rtlCol="0" anchor="ctr"/>
+          <a:lstStyle/>
+          <a:p>
+            <a:r>
+              <a:t>¿Por qué la banca presta a una empresa recién creada?</a:t>
+            </a:r>
+          </a:p>
+        </p:txBody>
+      </p:sp>
+      <p:sp>
+        <p:nvSpPr>
+          <p:cNvPr id="15" name="Text 13"/>
+          <p:cNvSpPr/>
+          <p:nvPr/>
+        </p:nvSpPr>
+        <p:spPr>
+          <a:xfrm>
+            <a:off x="749808" y="3483864"/>
+            <a:ext cx="5029200" cy="868680"/>
+          </a:xfrm>
+          <a:prstGeom prst="rect">
+            <a:avLst/>
+          </a:prstGeom>
+          <a:noFill/>
+          <a:ln/>
+        </p:spPr>
+        <p:txBody>
+          <a:bodyPr wrap="square" rtlCol="0" anchor="ctr"/>
+          <a:lstStyle/>
+          <a:p>
+            <a:r>
+              <a:t>Por la garantía estatal FOGAPE, que mitiga el 60–80 % del riesgo para PYMEs, y el 34 % de capital propio que los socios comprometen antes de solicitar el financiamiento bancario.</a:t>
+            </a:r>
+          </a:p>
+        </p:txBody>
+      </p:sp>
+      <p:sp>
+        <p:nvSpPr>
+          <p:cNvPr id="16" name="Shape 14"/>
+          <p:cNvSpPr/>
+          <p:nvPr/>
+        </p:nvSpPr>
+        <p:spPr>
+          <a:xfrm>
+            <a:off x="530352" y="4626864"/>
+            <a:ext cx="5440680" cy="1444752"/>
+          </a:xfrm>
+          <a:prstGeom prst="roundRect">
+            <a:avLst>
+              <a:gd name="adj" fmla="val 3165"/>
+            </a:avLst>
+          </a:prstGeom>
+          <a:solidFill>
+            <a:srgbClr val="FFFFFF"/>
+          </a:solidFill>
+          <a:ln w="12700">
+            <a:solidFill>
+              <a:srgbClr val="E8EAED"/>
+            </a:solidFill>
+            <a:prstDash val="solid"/>
+          </a:ln>
+        </p:spPr>
+      </p:sp>
+      <p:sp>
+        <p:nvSpPr>
+          <p:cNvPr id="17" name="Shape 15"/>
+          <p:cNvSpPr/>
+          <p:nvPr/>
+        </p:nvSpPr>
+        <p:spPr>
+          <a:xfrm>
+            <a:off x="530352" y="4626864"/>
+            <a:ext cx="45720" cy="1444752"/>
+          </a:xfrm>
+          <a:prstGeom prst="rect">
+            <a:avLst/>
+          </a:prstGeom>
+          <a:solidFill>
+            <a:srgbClr val="B02A26"/>
+          </a:solidFill>
+          <a:ln w="12700">
+            <a:solidFill>
+              <a:srgbClr val="B02A26"/>
+            </a:solidFill>
+            <a:prstDash val="solid"/>
+          </a:ln>
+        </p:spPr>
+      </p:sp>
+      <p:sp>
+        <p:nvSpPr>
+          <p:cNvPr id="18" name="Text 16"/>
+          <p:cNvSpPr/>
+          <p:nvPr/>
+        </p:nvSpPr>
+        <p:spPr>
+          <a:xfrm>
+            <a:off x="749808" y="4754880"/>
+            <a:ext cx="5029200" cy="292608"/>
+          </a:xfrm>
+          <a:prstGeom prst="rect">
+            <a:avLst/>
+          </a:prstGeom>
+          <a:noFill/>
+          <a:ln/>
+        </p:spPr>
+        <p:txBody>
+          <a:bodyPr wrap="square" rtlCol="0" anchor="ctr"/>
+          <a:lstStyle/>
+          <a:p>
+            <a:r>
+              <a:t>¿Por qué el flujo de caja del Año 1 es negativo (−$3,28 M)?</a:t>
+            </a:r>
+          </a:p>
+        </p:txBody>
+      </p:sp>
+      <p:sp>
+        <p:nvSpPr>
+          <p:cNvPr id="19" name="Text 17"/>
+          <p:cNvSpPr/>
+          <p:nvPr/>
+        </p:nvSpPr>
+        <p:spPr>
+          <a:xfrm>
+            <a:off x="749808" y="5084064"/>
+            <a:ext cx="5029200" cy="868680"/>
+          </a:xfrm>
+          <a:prstGeom prst="rect">
+            <a:avLst/>
+          </a:prstGeom>
+          <a:noFill/>
+          <a:ln/>
+        </p:spPr>
+        <p:txBody>
+          <a:bodyPr wrap="square" rtlCol="0" anchor="ctr"/>
+          <a:lstStyle/>
+          <a:p>
+            <a:r>
+              <a:t>La utilidad contable es positiva (+$2,99 M), pero el Año 1 se devuelve íntegro el capital de la línea corta ($5 M) más cuota LP ($2,07 M). Total $7,07 M pagados a banco, absorbidos por capital de trabajo.</a:t>
+            </a:r>
+          </a:p>
+        </p:txBody>
+      </p:sp>
+      <p:sp>
+        <p:nvSpPr>
+          <p:cNvPr id="20" name="Shape 18"/>
+          <p:cNvSpPr/>
+          <p:nvPr/>
+        </p:nvSpPr>
+        <p:spPr>
+          <a:xfrm>
+            <a:off x="6217920" y="1426464"/>
+            <a:ext cx="5440680" cy="1444752"/>
+          </a:xfrm>
+          <a:prstGeom prst="roundRect">
+            <a:avLst>
+              <a:gd name="adj" fmla="val 3165"/>
+            </a:avLst>
+          </a:prstGeom>
+          <a:solidFill>
+            <a:srgbClr val="FFFFFF"/>
+          </a:solidFill>
+          <a:ln w="12700">
+            <a:solidFill>
+              <a:srgbClr val="E8EAED"/>
+            </a:solidFill>
+            <a:prstDash val="solid"/>
+          </a:ln>
+        </p:spPr>
+      </p:sp>
+      <p:sp>
+        <p:nvSpPr>
+          <p:cNvPr id="21" name="Shape 19"/>
+          <p:cNvSpPr/>
+          <p:nvPr/>
+        </p:nvSpPr>
+        <p:spPr>
+          <a:xfrm>
+            <a:off x="6217920" y="1426464"/>
+            <a:ext cx="45720" cy="1444752"/>
+          </a:xfrm>
+          <a:prstGeom prst="rect">
+            <a:avLst/>
+          </a:prstGeom>
+          <a:solidFill>
+            <a:srgbClr val="B02A26"/>
+          </a:solidFill>
+          <a:ln w="12700">
+            <a:solidFill>
+              <a:srgbClr val="B02A26"/>
+            </a:solidFill>
+            <a:prstDash val="solid"/>
+          </a:ln>
+        </p:spPr>
+      </p:sp>
+      <p:sp>
+        <p:nvSpPr>
+          <p:cNvPr id="22" name="Text 20"/>
+          <p:cNvSpPr/>
+          <p:nvPr/>
+        </p:nvSpPr>
+        <p:spPr>
+          <a:xfrm>
+            <a:off x="6437376" y="1554480"/>
+            <a:ext cx="5029200" cy="292608"/>
+          </a:xfrm>
+          <a:prstGeom prst="rect">
+            <a:avLst/>
+          </a:prstGeom>
+          <a:noFill/>
+          <a:ln/>
+        </p:spPr>
+        <p:txBody>
+          <a:bodyPr wrap="square" rtlCol="0" anchor="ctr"/>
+          <a:lstStyle/>
+          <a:p>
+            <a:r>
+              <a:t>¿Cómo se dimensionó el capital de trabajo ($14,8 M)?</a:t>
+            </a:r>
+          </a:p>
+        </p:txBody>
+      </p:sp>
+      <p:sp>
+        <p:nvSpPr>
+          <p:cNvPr id="23" name="Text 21"/>
+          <p:cNvSpPr/>
+          <p:nvPr/>
+        </p:nvSpPr>
+        <p:spPr>
+          <a:xfrm>
+            <a:off x="6437376" y="1883664"/>
+            <a:ext cx="5029200" cy="868680"/>
+          </a:xfrm>
+          <a:prstGeom prst="rect">
+            <a:avLst/>
+          </a:prstGeom>
+          <a:noFill/>
+          <a:ln/>
+        </p:spPr>
+        <p:txBody>
+          <a:bodyPr wrap="square" rtlCol="0" anchor="ctr"/>
+          <a:lstStyle/>
+          <a:p>
+            <a:r>
+              <a:t>Cubre ~3 meses de gastos fijos de operación plena (incluyendo sueldos socios desde el mes 1) más la compra anticipada de 100 unidades ($7,06 M en insumos). Más $2,41 M de contingencia.</a:t>
+            </a:r>
+          </a:p>
+        </p:txBody>
+      </p:sp>
+      <p:sp>
+        <p:nvSpPr>
+          <p:cNvPr id="24" name="Shape 22"/>
+          <p:cNvSpPr/>
+          <p:nvPr/>
+        </p:nvSpPr>
+        <p:spPr>
+          <a:xfrm>
+            <a:off x="6217920" y="3026664"/>
+            <a:ext cx="5440680" cy="1444752"/>
+          </a:xfrm>
+          <a:prstGeom prst="roundRect">
+            <a:avLst>
+              <a:gd name="adj" fmla="val 3165"/>
+            </a:avLst>
+          </a:prstGeom>
+          <a:solidFill>
+            <a:srgbClr val="FFFFFF"/>
+          </a:solidFill>
+          <a:ln w="12700">
+            <a:solidFill>
+              <a:srgbClr val="E8EAED"/>
+            </a:solidFill>
+            <a:prstDash val="solid"/>
+          </a:ln>
+        </p:spPr>
+      </p:sp>
+      <p:sp>
+        <p:nvSpPr>
+          <p:cNvPr id="25" name="Shape 23"/>
+          <p:cNvSpPr/>
+          <p:nvPr/>
+        </p:nvSpPr>
+        <p:spPr>
+          <a:xfrm>
+            <a:off x="6217920" y="3026664"/>
+            <a:ext cx="45720" cy="1444752"/>
+          </a:xfrm>
+          <a:prstGeom prst="rect">
+            <a:avLst/>
+          </a:prstGeom>
+          <a:solidFill>
+            <a:srgbClr val="B02A26"/>
+          </a:solidFill>
+          <a:ln w="12700">
+            <a:solidFill>
+              <a:srgbClr val="B02A26"/>
+            </a:solidFill>
+            <a:prstDash val="solid"/>
+          </a:ln>
+        </p:spPr>
+      </p:sp>
+      <p:sp>
+        <p:nvSpPr>
+          <p:cNvPr id="26" name="Text 24"/>
+          <p:cNvSpPr/>
+          <p:nvPr/>
+        </p:nvSpPr>
+        <p:spPr>
+          <a:xfrm>
+            <a:off x="6437376" y="3154680"/>
+            <a:ext cx="5029200" cy="292608"/>
+          </a:xfrm>
+          <a:prstGeom prst="rect">
+            <a:avLst/>
+          </a:prstGeom>
+          <a:noFill/>
+          <a:ln/>
+        </p:spPr>
+        <p:txBody>
+          <a:bodyPr wrap="square" rtlCol="0" anchor="ctr"/>
+          <a:lstStyle/>
+          <a:p>
+            <a:r>
+              <a:t>¿Por qué no postulan a CORFO Semilla Inicia?</a:t>
+            </a:r>
+          </a:p>
+        </p:txBody>
+      </p:sp>
+      <p:sp>
+        <p:nvSpPr>
+          <p:cNvPr id="27" name="Text 25"/>
+          <p:cNvSpPr/>
+          <p:nvPr/>
+        </p:nvSpPr>
+        <p:spPr>
+          <a:xfrm>
+            <a:off x="6437376" y="3483864"/>
+            <a:ext cx="5029200" cy="868680"/>
+          </a:xfrm>
+          <a:prstGeom prst="rect">
+            <a:avLst/>
+          </a:prstGeom>
+          <a:noFill/>
+          <a:ln/>
+        </p:spPr>
+        <p:txBody>
+          <a:bodyPr wrap="square" rtlCol="0" anchor="ctr"/>
+          <a:lstStyle/>
+          <a:p>
+            <a:r>
+              <a:t>Por prudencia y autonomía financiera: el modelo debe sostenerse por sí mismo. Si se adjudica CORFO, sustituye deuda cara y mejora el retorno; si no, la empresa opera normalmente.</a:t>
+            </a:r>
+          </a:p>
+        </p:txBody>
+      </p:sp>
+      <p:sp>
+        <p:nvSpPr>
+          <p:cNvPr id="28" name="Shape 26"/>
+          <p:cNvSpPr/>
+          <p:nvPr/>
+        </p:nvSpPr>
+        <p:spPr>
+          <a:xfrm>
+            <a:off x="6217920" y="4626864"/>
+            <a:ext cx="5440680" cy="1444752"/>
+          </a:xfrm>
+          <a:prstGeom prst="roundRect">
+            <a:avLst>
+              <a:gd name="adj" fmla="val 3165"/>
+            </a:avLst>
+          </a:prstGeom>
+          <a:solidFill>
+            <a:srgbClr val="FFFFFF"/>
+          </a:solidFill>
+          <a:ln w="12700">
+            <a:solidFill>
+              <a:srgbClr val="E8EAED"/>
+            </a:solidFill>
+            <a:prstDash val="solid"/>
+          </a:ln>
+        </p:spPr>
+      </p:sp>
+      <p:sp>
+        <p:nvSpPr>
+          <p:cNvPr id="29" name="Shape 27"/>
+          <p:cNvSpPr/>
+          <p:nvPr/>
+        </p:nvSpPr>
+        <p:spPr>
+          <a:xfrm>
+            <a:off x="6217920" y="4626864"/>
+            <a:ext cx="45720" cy="1444752"/>
+          </a:xfrm>
+          <a:prstGeom prst="rect">
+            <a:avLst/>
+          </a:prstGeom>
+          <a:solidFill>
+            <a:srgbClr val="B02A26"/>
+          </a:solidFill>
+          <a:ln w="12700">
+            <a:solidFill>
+              <a:srgbClr val="B02A26"/>
+            </a:solidFill>
+            <a:prstDash val="solid"/>
+          </a:ln>
+        </p:spPr>
+      </p:sp>
+      <p:sp>
+        <p:nvSpPr>
+          <p:cNvPr id="30" name="Text 28"/>
+          <p:cNvSpPr/>
+          <p:nvPr/>
+        </p:nvSpPr>
+        <p:spPr>
+          <a:xfrm>
+            <a:off x="6437376" y="4754880"/>
+            <a:ext cx="5029200" cy="292608"/>
+          </a:xfrm>
+          <a:prstGeom prst="rect">
+            <a:avLst/>
+          </a:prstGeom>
+          <a:noFill/>
+          <a:ln/>
+        </p:spPr>
+        <p:txBody>
+          <a:bodyPr wrap="square" rtlCol="0" anchor="ctr"/>
+          <a:lstStyle/>
+          <a:p>
+            <a:r>
+              <a:t>¿Cómo evoluciona el retorno y flujo acumulado a 5 años?</a:t>
+            </a:r>
+          </a:p>
+        </p:txBody>
+      </p:sp>
+      <p:sp>
+        <p:nvSpPr>
+          <p:cNvPr id="31" name="Text 29"/>
+          <p:cNvSpPr/>
+          <p:nvPr/>
+        </p:nvSpPr>
+        <p:spPr>
+          <a:xfrm>
+            <a:off x="6437376" y="5084064"/>
+            <a:ext cx="5029200" cy="868680"/>
+          </a:xfrm>
+          <a:prstGeom prst="rect">
+            <a:avLst/>
+          </a:prstGeom>
+          <a:noFill/>
+          <a:ln/>
+        </p:spPr>
+        <p:txBody>
+          <a:bodyPr wrap="square" rtlCol="0" anchor="ctr"/>
+          <a:lstStyle/>
+          <a:p>
+            <a:r>
+              <a:t>Flujos anuales positivos: $8,27 M (Año 2), $7,65 M (Año 3), $19,58 M (Año 4) y $30,49 M (Año 5). Cruza a positivo en 3,71 años (Payback) cerrando en $36,17 M acumulados (VAN $2,59 M, TIR 22,7 %).</a:t>
+            </a:r>
+          </a:p>
+        </p:txBody>
+      </p:sp>
+    </p:spTree>
+  </p:cSld>
+  <p:clrMapOvr>
+    <a:masterClrMapping/>
+  </p:clrMapOvr>
+</p:sld>
+</file>
+
 <file path=ppt/slides/slide2.xml><?xml version="1.0" encoding="utf-8"?>
 <p:sld xmlns:a="http://schemas.openxmlformats.org/drawingml/2006/main" xmlns:r="http://schemas.openxmlformats.org/officeDocument/2006/relationships" xmlns:p="http://schemas.openxmlformats.org/presentationml/2006/main">
   <p:cSld name="Slide 2">

</xml_diff>